<commit_message>
Präsentation mit QR-Code; Generator nicht mehr im Repository
- Schlussfolie mit QR-Code auf den Beitrag auf piu.de
- Trainingszeit von v2 in den Sprechernotizen korrigiert
- praesentation/build_deck.js aus dem Repository entfernt und ignoriert

Co-Authored-By: Claude Opus 5.5 <noreply@anthropic.com>
</commit_message>
<xml_diff>
--- a/praesentation/Vertical_AI_KYC.pptx
+++ b/praesentation/Vertical_AI_KYC.pptx
@@ -118,20 +118,20 @@
   <p:extLst>
     <p:ext uri="{521415D9-36F7-43E2-AB2F-B90AF26B5E84}">
       <p14:sectionLst xmlns:p14="http://schemas.microsoft.com/office/powerpoint/2010/main">
-        <p14:section name="Einstieg" id="{1dd13924-1de8-7080-a03b-9405e68dc10c}">
+        <p14:section name="Einstieg" id="{e257b48e-c2d1-a494-7bee-105dc74b46b3}">
           <p14:sldIdLst>
             <p14:sldId id="256"/>
             <p14:sldId id="257"/>
           </p14:sldIdLst>
         </p14:section>
-        <p14:section name="Use Case und Prozess" id="{f1b358f4-d661-0e16-2721-aa272c54ae90}">
+        <p14:section name="Use Case und Prozess" id="{e2ea1be2-5bb0-53f1-7ca4-5bbc4bc5a06c}">
           <p14:sldIdLst>
             <p14:sldId id="258"/>
             <p14:sldId id="259"/>
             <p14:sldId id="260"/>
           </p14:sldIdLst>
         </p14:section>
-        <p14:section name="Daten und Modell" id="{6600d2bd-7de9-cd96-bccf-a8cbce51dc35}">
+        <p14:section name="Daten und Modell" id="{28483d0e-f409-b2e8-14b0-f55a9d311242}">
           <p14:sldIdLst>
             <p14:sldId id="261"/>
             <p14:sldId id="262"/>
@@ -139,13 +139,13 @@
             <p14:sldId id="264"/>
           </p14:sldIdLst>
         </p14:section>
-        <p14:section name="Demo" id="{4c690564-a38e-1468-34f4-eefd568a1519}">
+        <p14:section name="Demo" id="{94e01eba-3572-7b55-7069-b601055b66e9}">
           <p14:sldIdLst>
             <p14:sldId id="265"/>
             <p14:sldId id="266"/>
           </p14:sldIdLst>
         </p14:section>
-        <p14:section name="Abschluss" id="{234a43be-0d71-a87c-0adb-affc18e4f057}">
+        <p14:section name="Abschluss" id="{4ce7df37-63c6-7fa9-9d50-15ffd2982d04}">
           <p14:sldIdLst>
             <p14:sldId id="267"/>
           </p14:sldIdLst>
@@ -818,7 +818,7 @@
           <a:p>
             <a:r>
               <a:rPr lang="en-US" dirty="0"/>
-              <a:t>15 Minuten Fragerunde.</a:t>
+              <a:t>15 Minuten Fragerunde. Der QR-Code führt zum Beitrag auf piu.de (https://www.piu.de/vertical-ai-im-kyc-prozess/); dort steht der Link zum GitHub-Repository mit Code, Daten und Modell.</a:t>
             </a:r>
             <a:endParaRPr lang="en-US" dirty="0"/>
           </a:p>
@@ -1439,7 +1439,7 @@
           <a:p>
             <a:r>
               <a:rPr lang="en-US" dirty="0"/>
-              <a:t>Gemessen auf einem Mac M1 Max: 5.000 Datensätze (4.000 Training, 3 Epochen) in 97,6 Minuten; v2 mit 6.000 Datensätzen (2 Epochen) in 66 Minuten. Das sind rund 0,45 Sekunden je Trainingsfall und Epoche. Die übrigen Werte sind linear hochgerechnet (80 % Training, 3 Epochen): 20.000 in etwa 6 Stunden, 50.000 in etwa 15 Stunden – also über Nacht. 1.000.000 bräuchte auf dem Mac rund 12 Tage; bei so vielen Daten reicht oft 1 Epoche (rund 4 Tage), sinnvoller ist dann ein GPU-Server (nicht gemessen). Wiederholen: Daten ergänzen (augment_dataset.py, Sekunden), trainieren (kyc_train.py), prüfen mit Testsplit und Gegenproben (Minuten), dann im Laya-Dienst das Modell tauschen (LAYA_MODEL, Neustart in Sekunden). BPMN und DMN bleiben unverändert. Beispiel v2: Die Reeperbahn-Abkürzung wurde mit 1.000 neuen Varianten in gut einer Stunde Training behoben; trainiert wurde ab dem Zwischenstand nach Epoche 1, nicht von vorn.</a:t>
+              <a:t>Gemessen auf einem Mac M1 Max: 5.000 Datensätze (4.000 Training, 3 Epochen) in 97,6 Minuten; v2 mit 6.000 Datensätzen (2 Epochen) in 66 Minuten. Das sind rund 0,45 Sekunden je Trainingsfall und Epoche. Die übrigen Werte sind linear hochgerechnet (80 % Training, 3 Epochen): 20.000 in etwa 6 Stunden, 50.000 in etwa 15 Stunden – also über Nacht. 1.000.000 bräuchte auf dem Mac rund 12 Tage; bei so vielen Daten reicht oft 1 Epoche (rund 4 Tage), sinnvoller ist dann ein GPU-Server (nicht gemessen). Wiederholen: Daten ergänzen (augment_dataset.py, Sekunden), trainieren (kyc_train.py), prüfen mit Testsplit und Gegenproben (Minuten), dann im Laya-Dienst das Modell tauschen (LAYA_MODEL, Neustart in Sekunden). BPMN und DMN bleiben unverändert. Beispiel v2: Die Reeperbahn-Abkürzung wurde mit 1.000 neuen Varianten in rund 1 Stunde 40 Minuten Training behoben: ein erster Lauf bis Epoche 1 (36 Minuten), dann ab diesem Zwischenstand weiter (66 Minuten).</a:t>
             </a:r>
             <a:endParaRPr lang="en-US" dirty="0"/>
           </a:p>
@@ -3969,6 +3969,66 @@
             <a:prstDash val="solid"/>
           </a:ln>
         </p:spPr>
+      </p:sp>
+      <p:pic>
+        <p:nvPicPr>
+          <p:cNvPr id="7" name="QR-Code Beitrag" descr="QR-Code: Beitrag zum Vortrag auf piu.de, https://www.piu.de/vertical-ai-im-kyc-prozess/">    </p:cNvPr>
+          <p:cNvPicPr>
+            <a:picLocks noChangeAspect="1"/>
+          </p:cNvPicPr>
+          <p:nvPr/>
+        </p:nvPicPr>
+        <p:blipFill>
+          <a:blip r:embed="rId1"/>
+          <a:stretch>
+            <a:fillRect/>
+          </a:stretch>
+        </p:blipFill>
+        <p:spPr>
+          <a:xfrm>
+            <a:off x="9448495" y="2240280"/>
+            <a:ext cx="2194560" cy="2194560"/>
+          </a:xfrm>
+          <a:prstGeom prst="rect">
+            <a:avLst/>
+          </a:prstGeom>
+        </p:spPr>
+      </p:pic>
+      <p:sp>
+        <p:nvSpPr>
+          <p:cNvPr id="8" name="QR-Beschriftung"/>
+          <p:cNvSpPr txBox="1"/>
+          <p:nvPr/>
+        </p:nvSpPr>
+        <p:spPr>
+          <a:xfrm>
+            <a:off x="8991295" y="4526280"/>
+            <a:ext cx="3108960" cy="365760"/>
+          </a:xfrm>
+          <a:prstGeom prst="rect">
+            <a:avLst/>
+          </a:prstGeom>
+          <a:noFill/>
+          <a:ln/>
+        </p:spPr>
+        <p:txBody>
+          <a:bodyPr wrap="square" lIns="0" tIns="0" rIns="0" bIns="0" rtlCol="0" anchor="ctr"/>
+          <a:lstStyle/>
+          <a:p>
+            <a:pPr algn="ctr" indent="0" marL="0">
+              <a:buNone/>
+            </a:pPr>
+            <a:r>
+              <a:rPr lang="en-US" sz="1300" dirty="0">
+                <a:solidFill>
+                  <a:srgbClr val="757575"/>
+                </a:solidFill>
+              </a:rPr>
+              <a:t>Beitrag, Code und Modell</a:t>
+            </a:r>
+            <a:endParaRPr lang="en-US" sz="1300" dirty="0"/>
+          </a:p>
+        </p:txBody>
       </p:sp>
     </p:spTree>
   </p:cSld>

</xml_diff>